<commit_message>
Modos con letras A-D y colores de la presentación general
Co-Authored-By: Claude Sonnet 5.5 <noreply@anthropic.com>
Claude-Session: https://claude.ai/code/session_019rwwpB11eUvepuXCyo8xZP
</commit_message>
<xml_diff>
--- a/Estilos_de_pensamiento.pptx
+++ b/Estilos_de_pensamiento.pptx
@@ -663,7 +663,7 @@
           <a:p/>
           <a:p>
             <a:r>
-              <a:t>Equivalencia con la presentación general (A–D): modo 4 = A (frontal izquierdo), modo 3 = D (frontal derecho), modo 1 = B (basal izquierdo), modo 2 = C (basal derecho).</a:t>
+              <a:t>Los modos usan las mismas letras y colores que la presentación general: A azul (frontal izquierdo), D amarillo (frontal derecho), B verde (basal izquierdo), C rojo (basal derecho).</a:t>
             </a:r>
           </a:p>
         </p:txBody>
@@ -873,7 +873,7 @@
           <a:lstStyle/>
           <a:p>
             <a:r>
-              <a:t>Es una lectura del grupo, no un diagnóstico de personas. El modo III es el menos dominante como primera preferencia, pero cuatro personas lo tienen arriba y seis superan los 12 puntos. Preguntar al grupo si esto coincide con lo que viven en el trabajo.</a:t>
+              <a:t>Es una lectura del grupo, no un diagnóstico de personas. El modo D es el menos dominante como primera preferencia, pero cuatro personas lo tienen arriba y seis superan los 12 puntos. Preguntar al grupo si esto coincide con lo que viven en el trabajo.</a:t>
             </a:r>
           </a:p>
         </p:txBody>
@@ -2021,7 +2021,7 @@
                 <a:ea typeface="Caveat Brush" pitchFamily="18" charset="-122"/>
                 <a:cs typeface="Caveat Brush" pitchFamily="18" charset="-120"/>
               </a:rPr>
-              <a:t>4</a:t>
+              <a:t>A</a:t>
             </a:r>
             <a:endParaRPr lang="en-US" sz="5500" dirty="0"/>
           </a:p>
@@ -2095,7 +2095,7 @@
                 <a:ea typeface="Caveat Brush" pitchFamily="18" charset="-122"/>
                 <a:cs typeface="Caveat Brush" pitchFamily="18" charset="-120"/>
               </a:rPr>
-              <a:t>3</a:t>
+              <a:t>D</a:t>
             </a:r>
             <a:endParaRPr lang="en-US" sz="5500" dirty="0"/>
           </a:p>
@@ -2169,7 +2169,7 @@
                 <a:ea typeface="Caveat Brush" pitchFamily="18" charset="-122"/>
                 <a:cs typeface="Caveat Brush" pitchFamily="18" charset="-120"/>
               </a:rPr>
-              <a:t>1</a:t>
+              <a:t>B</a:t>
             </a:r>
             <a:endParaRPr lang="en-US" sz="5500" dirty="0"/>
           </a:p>
@@ -2243,7 +2243,7 @@
                 <a:ea typeface="Caveat Brush" pitchFamily="18" charset="-122"/>
                 <a:cs typeface="Caveat Brush" pitchFamily="18" charset="-120"/>
               </a:rPr>
-              <a:t>2</a:t>
+              <a:t>C</a:t>
             </a:r>
             <a:endParaRPr lang="en-US" sz="5500" dirty="0"/>
           </a:p>
@@ -2458,7 +2458,7 @@
                 </a:solidFill>
                 <a:latin typeface="Caveat Brush"/>
               </a:rPr>
-              <a:t>1</a:t>
+              <a:t>B</a:t>
             </a:r>
           </a:p>
         </p:txBody>
@@ -2539,7 +2539,7 @@
                 </a:solidFill>
                 <a:latin typeface="Caveat Brush"/>
               </a:rPr>
-              <a:t>2</a:t>
+              <a:t>C</a:t>
             </a:r>
           </a:p>
         </p:txBody>
@@ -2620,7 +2620,7 @@
                 </a:solidFill>
                 <a:latin typeface="Caveat Brush"/>
               </a:rPr>
-              <a:t>3</a:t>
+              <a:t>D</a:t>
             </a:r>
           </a:p>
         </p:txBody>
@@ -2701,7 +2701,7 @@
                 </a:solidFill>
                 <a:latin typeface="Caveat Brush"/>
               </a:rPr>
-              <a:t>4</a:t>
+              <a:t>A</a:t>
             </a:r>
           </a:p>
         </p:txBody>
@@ -3055,7 +3055,7 @@
                 </a:solidFill>
                 <a:latin typeface="Caveat Brush"/>
               </a:rPr>
-              <a:t>1</a:t>
+              <a:t>B</a:t>
             </a:r>
           </a:p>
         </p:txBody>
@@ -3090,7 +3090,7 @@
                 </a:solidFill>
                 <a:latin typeface="Roboto Condensed"/>
               </a:rPr>
-              <a:t>MODO 1 · VERDE</a:t>
+              <a:t>MODO B · VERDE</a:t>
             </a:r>
           </a:p>
         </p:txBody>
@@ -3245,7 +3245,7 @@
                 </a:solidFill>
                 <a:latin typeface="Caveat Brush"/>
               </a:rPr>
-              <a:t>2</a:t>
+              <a:t>C</a:t>
             </a:r>
           </a:p>
         </p:txBody>
@@ -3280,7 +3280,7 @@
                 </a:solidFill>
                 <a:latin typeface="Roboto Condensed"/>
               </a:rPr>
-              <a:t>MODO 2 · ROJO</a:t>
+              <a:t>MODO C · ROJO</a:t>
             </a:r>
           </a:p>
         </p:txBody>
@@ -3435,7 +3435,7 @@
                 </a:solidFill>
                 <a:latin typeface="Caveat Brush"/>
               </a:rPr>
-              <a:t>3</a:t>
+              <a:t>D</a:t>
             </a:r>
           </a:p>
         </p:txBody>
@@ -3470,7 +3470,7 @@
                 </a:solidFill>
                 <a:latin typeface="Roboto Condensed"/>
               </a:rPr>
-              <a:t>MODO 3 · AMARILLO</a:t>
+              <a:t>MODO D · AMARILLO</a:t>
             </a:r>
           </a:p>
         </p:txBody>
@@ -3625,7 +3625,7 @@
                 </a:solidFill>
                 <a:latin typeface="Caveat Brush"/>
               </a:rPr>
-              <a:t>4</a:t>
+              <a:t>A</a:t>
             </a:r>
           </a:p>
         </p:txBody>
@@ -3660,7 +3660,7 @@
                 </a:solidFill>
                 <a:latin typeface="Roboto Condensed"/>
               </a:rPr>
-              <a:t>MODO 4 · AZUL</a:t>
+              <a:t>MODO A · AZUL</a:t>
             </a:r>
           </a:p>
         </p:txBody>
@@ -3933,7 +3933,7 @@
                 </a:solidFill>
                 <a:latin typeface="Inter"/>
               </a:rPr>
-              <a:t>1 · Orden y procesos</a:t>
+              <a:t>A · Análisis y estrategia</a:t>
             </a:r>
           </a:p>
         </p:txBody>
@@ -3993,6 +3993,168 @@
         <p:spPr>
           <a:xfrm>
             <a:off x="3810000" y="2336800"/>
+            <a:ext cx="3238500" cy="406400"/>
+          </a:xfrm>
+          <a:prstGeom prst="roundRect">
+            <a:avLst>
+              <a:gd name="adj" fmla="val 20000"/>
+            </a:avLst>
+          </a:prstGeom>
+          <a:solidFill>
+            <a:srgbClr val="2B5C9A"/>
+          </a:solidFill>
+          <a:ln>
+            <a:noFill/>
+          </a:ln>
+          <a:effectLst/>
+        </p:spPr>
+        <p:style>
+          <a:lnRef idx="1">
+            <a:schemeClr val="accent1"/>
+          </a:lnRef>
+          <a:fillRef idx="3">
+            <a:schemeClr val="accent1"/>
+          </a:fillRef>
+          <a:effectRef idx="2">
+            <a:schemeClr val="accent1"/>
+          </a:effectRef>
+          <a:fontRef idx="minor">
+            <a:schemeClr val="lt1"/>
+          </a:fontRef>
+        </p:style>
+        <p:txBody>
+          <a:bodyPr rtlCol="0" anchor="ctr"/>
+          <a:lstStyle/>
+          <a:p>
+            <a:pPr algn="ctr"/>
+          </a:p>
+        </p:txBody>
+      </p:sp>
+      <p:sp>
+        <p:nvSpPr>
+          <p:cNvPr id="8" name="TextBox 7"/>
+          <p:cNvSpPr txBox="1"/>
+          <p:nvPr/>
+        </p:nvSpPr>
+        <p:spPr>
+          <a:xfrm>
+            <a:off x="10363200" y="2311400"/>
+            <a:ext cx="1016000" cy="457200"/>
+          </a:xfrm>
+          <a:prstGeom prst="rect">
+            <a:avLst/>
+          </a:prstGeom>
+          <a:noFill/>
+        </p:spPr>
+        <p:txBody>
+          <a:bodyPr wrap="square" lIns="0" rIns="0" tIns="0" bIns="0" anchor="ctr">
+            <a:spAutoFit/>
+          </a:bodyPr>
+          <a:lstStyle/>
+          <a:p>
+            <a:pPr algn="l"/>
+            <a:r>
+              <a:rPr sz="2200" b="0" i="0">
+                <a:solidFill>
+                  <a:srgbClr val="002060"/>
+                </a:solidFill>
+                <a:latin typeface="Caveat Brush"/>
+              </a:rPr>
+              <a:t>10,2</a:t>
+            </a:r>
+          </a:p>
+        </p:txBody>
+      </p:sp>
+      <p:sp>
+        <p:nvSpPr>
+          <p:cNvPr id="9" name="TextBox 8"/>
+          <p:cNvSpPr txBox="1"/>
+          <p:nvPr/>
+        </p:nvSpPr>
+        <p:spPr>
+          <a:xfrm>
+            <a:off x="812800" y="3022600"/>
+            <a:ext cx="2921000" cy="457200"/>
+          </a:xfrm>
+          <a:prstGeom prst="rect">
+            <a:avLst/>
+          </a:prstGeom>
+          <a:noFill/>
+        </p:spPr>
+        <p:txBody>
+          <a:bodyPr wrap="square" lIns="0" rIns="0" tIns="0" bIns="0" anchor="ctr">
+            <a:spAutoFit/>
+          </a:bodyPr>
+          <a:lstStyle/>
+          <a:p>
+            <a:pPr algn="l"/>
+            <a:r>
+              <a:rPr sz="1600" b="1" i="0">
+                <a:solidFill>
+                  <a:srgbClr val="002060"/>
+                </a:solidFill>
+                <a:latin typeface="Inter"/>
+              </a:rPr>
+              <a:t>B · Orden y procesos</a:t>
+            </a:r>
+          </a:p>
+        </p:txBody>
+      </p:sp>
+      <p:sp>
+        <p:nvSpPr>
+          <p:cNvPr id="10" name="Rounded Rectangle 9"/>
+          <p:cNvSpPr/>
+          <p:nvPr/>
+        </p:nvSpPr>
+        <p:spPr>
+          <a:xfrm>
+            <a:off x="3810000" y="3048000"/>
+            <a:ext cx="6350000" cy="406400"/>
+          </a:xfrm>
+          <a:prstGeom prst="roundRect">
+            <a:avLst>
+              <a:gd name="adj" fmla="val 20000"/>
+            </a:avLst>
+          </a:prstGeom>
+          <a:solidFill>
+            <a:srgbClr val="EFEBDD"/>
+          </a:solidFill>
+          <a:ln>
+            <a:noFill/>
+          </a:ln>
+          <a:effectLst/>
+        </p:spPr>
+        <p:style>
+          <a:lnRef idx="1">
+            <a:schemeClr val="accent1"/>
+          </a:lnRef>
+          <a:fillRef idx="3">
+            <a:schemeClr val="accent1"/>
+          </a:fillRef>
+          <a:effectRef idx="2">
+            <a:schemeClr val="accent1"/>
+          </a:effectRef>
+          <a:fontRef idx="minor">
+            <a:schemeClr val="lt1"/>
+          </a:fontRef>
+        </p:style>
+        <p:txBody>
+          <a:bodyPr rtlCol="0" anchor="ctr"/>
+          <a:lstStyle/>
+          <a:p>
+            <a:pPr algn="ctr"/>
+          </a:p>
+        </p:txBody>
+      </p:sp>
+      <p:sp>
+        <p:nvSpPr>
+          <p:cNvPr id="11" name="Rounded Rectangle 10"/>
+          <p:cNvSpPr/>
+          <p:nvPr/>
+        </p:nvSpPr>
+        <p:spPr>
+          <a:xfrm>
+            <a:off x="3810000" y="3048000"/>
             <a:ext cx="2921000" cy="406400"/>
           </a:xfrm>
           <a:prstGeom prst="roundRect">
@@ -4032,13 +4194,13 @@
       </p:sp>
       <p:sp>
         <p:nvSpPr>
-          <p:cNvPr id="8" name="TextBox 7"/>
-          <p:cNvSpPr txBox="1"/>
-          <p:nvPr/>
-        </p:nvSpPr>
-        <p:spPr>
-          <a:xfrm>
-            <a:off x="10363200" y="2311400"/>
+          <p:cNvPr id="12" name="TextBox 11"/>
+          <p:cNvSpPr txBox="1"/>
+          <p:nvPr/>
+        </p:nvSpPr>
+        <p:spPr>
+          <a:xfrm>
+            <a:off x="10363200" y="3022600"/>
             <a:ext cx="1016000" cy="457200"/>
           </a:xfrm>
           <a:prstGeom prst="rect">
@@ -4067,13 +4229,13 @@
       </p:sp>
       <p:sp>
         <p:nvSpPr>
-          <p:cNvPr id="9" name="TextBox 8"/>
-          <p:cNvSpPr txBox="1"/>
-          <p:nvPr/>
-        </p:nvSpPr>
-        <p:spPr>
-          <a:xfrm>
-            <a:off x="812800" y="3022600"/>
+          <p:cNvPr id="13" name="TextBox 12"/>
+          <p:cNvSpPr txBox="1"/>
+          <p:nvPr/>
+        </p:nvSpPr>
+        <p:spPr>
+          <a:xfrm>
+            <a:off x="812800" y="3733800"/>
             <a:ext cx="2921000" cy="457200"/>
           </a:xfrm>
           <a:prstGeom prst="rect">
@@ -4095,20 +4257,20 @@
                 </a:solidFill>
                 <a:latin typeface="Inter"/>
               </a:rPr>
-              <a:t>2 · Personas y vínculos</a:t>
-            </a:r>
-          </a:p>
-        </p:txBody>
-      </p:sp>
-      <p:sp>
-        <p:nvSpPr>
-          <p:cNvPr id="10" name="Rounded Rectangle 9"/>
+              <a:t>C · Personas y vínculos</a:t>
+            </a:r>
+          </a:p>
+        </p:txBody>
+      </p:sp>
+      <p:sp>
+        <p:nvSpPr>
+          <p:cNvPr id="14" name="Rounded Rectangle 13"/>
           <p:cNvSpPr/>
           <p:nvPr/>
         </p:nvSpPr>
         <p:spPr>
           <a:xfrm>
-            <a:off x="3810000" y="3048000"/>
+            <a:off x="3810000" y="3759200"/>
             <a:ext cx="6350000" cy="406400"/>
           </a:xfrm>
           <a:prstGeom prst="roundRect">
@@ -4148,13 +4310,13 @@
       </p:sp>
       <p:sp>
         <p:nvSpPr>
-          <p:cNvPr id="11" name="Rounded Rectangle 10"/>
+          <p:cNvPr id="15" name="Rounded Rectangle 14"/>
           <p:cNvSpPr/>
           <p:nvPr/>
         </p:nvSpPr>
         <p:spPr>
           <a:xfrm>
-            <a:off x="3810000" y="3048000"/>
+            <a:off x="3810000" y="3759200"/>
             <a:ext cx="2952750" cy="406400"/>
           </a:xfrm>
           <a:prstGeom prst="roundRect">
@@ -4194,13 +4356,13 @@
       </p:sp>
       <p:sp>
         <p:nvSpPr>
-          <p:cNvPr id="12" name="TextBox 11"/>
-          <p:cNvSpPr txBox="1"/>
-          <p:nvPr/>
-        </p:nvSpPr>
-        <p:spPr>
-          <a:xfrm>
-            <a:off x="10363200" y="3022600"/>
+          <p:cNvPr id="16" name="TextBox 15"/>
+          <p:cNvSpPr txBox="1"/>
+          <p:nvPr/>
+        </p:nvSpPr>
+        <p:spPr>
+          <a:xfrm>
+            <a:off x="10363200" y="3733800"/>
             <a:ext cx="1016000" cy="457200"/>
           </a:xfrm>
           <a:prstGeom prst="rect">
@@ -4229,13 +4391,13 @@
       </p:sp>
       <p:sp>
         <p:nvSpPr>
-          <p:cNvPr id="13" name="TextBox 12"/>
-          <p:cNvSpPr txBox="1"/>
-          <p:nvPr/>
-        </p:nvSpPr>
-        <p:spPr>
-          <a:xfrm>
-            <a:off x="812800" y="3733800"/>
+          <p:cNvPr id="17" name="TextBox 16"/>
+          <p:cNvSpPr txBox="1"/>
+          <p:nvPr/>
+        </p:nvSpPr>
+        <p:spPr>
+          <a:xfrm>
+            <a:off x="812800" y="4445000"/>
             <a:ext cx="2921000" cy="457200"/>
           </a:xfrm>
           <a:prstGeom prst="rect">
@@ -4257,20 +4419,20 @@
                 </a:solidFill>
                 <a:latin typeface="Inter"/>
               </a:rPr>
-              <a:t>3 · Visión e intuición</a:t>
-            </a:r>
-          </a:p>
-        </p:txBody>
-      </p:sp>
-      <p:sp>
-        <p:nvSpPr>
-          <p:cNvPr id="14" name="Rounded Rectangle 13"/>
+              <a:t>D · Visión e intuición</a:t>
+            </a:r>
+          </a:p>
+        </p:txBody>
+      </p:sp>
+      <p:sp>
+        <p:nvSpPr>
+          <p:cNvPr id="18" name="Rounded Rectangle 17"/>
           <p:cNvSpPr/>
           <p:nvPr/>
         </p:nvSpPr>
         <p:spPr>
           <a:xfrm>
-            <a:off x="3810000" y="3759200"/>
+            <a:off x="3810000" y="4470400"/>
             <a:ext cx="6350000" cy="406400"/>
           </a:xfrm>
           <a:prstGeom prst="roundRect">
@@ -4310,13 +4472,13 @@
       </p:sp>
       <p:sp>
         <p:nvSpPr>
-          <p:cNvPr id="15" name="Rounded Rectangle 14"/>
+          <p:cNvPr id="19" name="Rounded Rectangle 18"/>
           <p:cNvSpPr/>
           <p:nvPr/>
         </p:nvSpPr>
         <p:spPr>
           <a:xfrm>
-            <a:off x="3810000" y="3759200"/>
+            <a:off x="3810000" y="4470400"/>
             <a:ext cx="2952750" cy="406400"/>
           </a:xfrm>
           <a:prstGeom prst="roundRect">
@@ -4356,168 +4518,6 @@
       </p:sp>
       <p:sp>
         <p:nvSpPr>
-          <p:cNvPr id="16" name="TextBox 15"/>
-          <p:cNvSpPr txBox="1"/>
-          <p:nvPr/>
-        </p:nvSpPr>
-        <p:spPr>
-          <a:xfrm>
-            <a:off x="10363200" y="3733800"/>
-            <a:ext cx="1016000" cy="457200"/>
-          </a:xfrm>
-          <a:prstGeom prst="rect">
-            <a:avLst/>
-          </a:prstGeom>
-          <a:noFill/>
-        </p:spPr>
-        <p:txBody>
-          <a:bodyPr wrap="square" lIns="0" rIns="0" tIns="0" bIns="0" anchor="ctr">
-            <a:spAutoFit/>
-          </a:bodyPr>
-          <a:lstStyle/>
-          <a:p>
-            <a:pPr algn="l"/>
-            <a:r>
-              <a:rPr sz="2200" b="0" i="0">
-                <a:solidFill>
-                  <a:srgbClr val="002060"/>
-                </a:solidFill>
-                <a:latin typeface="Caveat Brush"/>
-              </a:rPr>
-              <a:t>9,3</a:t>
-            </a:r>
-          </a:p>
-        </p:txBody>
-      </p:sp>
-      <p:sp>
-        <p:nvSpPr>
-          <p:cNvPr id="17" name="TextBox 16"/>
-          <p:cNvSpPr txBox="1"/>
-          <p:nvPr/>
-        </p:nvSpPr>
-        <p:spPr>
-          <a:xfrm>
-            <a:off x="812800" y="4445000"/>
-            <a:ext cx="2921000" cy="457200"/>
-          </a:xfrm>
-          <a:prstGeom prst="rect">
-            <a:avLst/>
-          </a:prstGeom>
-          <a:noFill/>
-        </p:spPr>
-        <p:txBody>
-          <a:bodyPr wrap="square" lIns="0" rIns="0" tIns="0" bIns="0" anchor="ctr">
-            <a:spAutoFit/>
-          </a:bodyPr>
-          <a:lstStyle/>
-          <a:p>
-            <a:pPr algn="l"/>
-            <a:r>
-              <a:rPr sz="1600" b="1" i="0">
-                <a:solidFill>
-                  <a:srgbClr val="002060"/>
-                </a:solidFill>
-                <a:latin typeface="Inter"/>
-              </a:rPr>
-              <a:t>4 · Análisis y estrategia</a:t>
-            </a:r>
-          </a:p>
-        </p:txBody>
-      </p:sp>
-      <p:sp>
-        <p:nvSpPr>
-          <p:cNvPr id="18" name="Rounded Rectangle 17"/>
-          <p:cNvSpPr/>
-          <p:nvPr/>
-        </p:nvSpPr>
-        <p:spPr>
-          <a:xfrm>
-            <a:off x="3810000" y="4470400"/>
-            <a:ext cx="6350000" cy="406400"/>
-          </a:xfrm>
-          <a:prstGeom prst="roundRect">
-            <a:avLst>
-              <a:gd name="adj" fmla="val 20000"/>
-            </a:avLst>
-          </a:prstGeom>
-          <a:solidFill>
-            <a:srgbClr val="EFEBDD"/>
-          </a:solidFill>
-          <a:ln>
-            <a:noFill/>
-          </a:ln>
-          <a:effectLst/>
-        </p:spPr>
-        <p:style>
-          <a:lnRef idx="1">
-            <a:schemeClr val="accent1"/>
-          </a:lnRef>
-          <a:fillRef idx="3">
-            <a:schemeClr val="accent1"/>
-          </a:fillRef>
-          <a:effectRef idx="2">
-            <a:schemeClr val="accent1"/>
-          </a:effectRef>
-          <a:fontRef idx="minor">
-            <a:schemeClr val="lt1"/>
-          </a:fontRef>
-        </p:style>
-        <p:txBody>
-          <a:bodyPr rtlCol="0" anchor="ctr"/>
-          <a:lstStyle/>
-          <a:p>
-            <a:pPr algn="ctr"/>
-          </a:p>
-        </p:txBody>
-      </p:sp>
-      <p:sp>
-        <p:nvSpPr>
-          <p:cNvPr id="19" name="Rounded Rectangle 18"/>
-          <p:cNvSpPr/>
-          <p:nvPr/>
-        </p:nvSpPr>
-        <p:spPr>
-          <a:xfrm>
-            <a:off x="3810000" y="4470400"/>
-            <a:ext cx="3238500" cy="406400"/>
-          </a:xfrm>
-          <a:prstGeom prst="roundRect">
-            <a:avLst>
-              <a:gd name="adj" fmla="val 20000"/>
-            </a:avLst>
-          </a:prstGeom>
-          <a:solidFill>
-            <a:srgbClr val="2B5C9A"/>
-          </a:solidFill>
-          <a:ln>
-            <a:noFill/>
-          </a:ln>
-          <a:effectLst/>
-        </p:spPr>
-        <p:style>
-          <a:lnRef idx="1">
-            <a:schemeClr val="accent1"/>
-          </a:lnRef>
-          <a:fillRef idx="3">
-            <a:schemeClr val="accent1"/>
-          </a:fillRef>
-          <a:effectRef idx="2">
-            <a:schemeClr val="accent1"/>
-          </a:effectRef>
-          <a:fontRef idx="minor">
-            <a:schemeClr val="lt1"/>
-          </a:fontRef>
-        </p:style>
-        <p:txBody>
-          <a:bodyPr rtlCol="0" anchor="ctr"/>
-          <a:lstStyle/>
-          <a:p>
-            <a:pPr algn="ctr"/>
-          </a:p>
-        </p:txBody>
-      </p:sp>
-      <p:sp>
-        <p:nvSpPr>
           <p:cNvPr id="20" name="TextBox 19"/>
           <p:cNvSpPr txBox="1"/>
           <p:nvPr/>
@@ -4546,7 +4546,7 @@
                 </a:solidFill>
                 <a:latin typeface="Caveat Brush"/>
               </a:rPr>
-              <a:t>10,2</a:t>
+              <a:t>9,3</a:t>
             </a:r>
           </a:p>
         </p:txBody>
@@ -4905,7 +4905,7 @@
                 </a:solidFill>
                 <a:latin typeface="Roboto Condensed"/>
               </a:rPr>
-              <a:t>MODO 1 · VERDE</a:t>
+              <a:t>MODO B · VERDE</a:t>
             </a:r>
           </a:p>
         </p:txBody>
@@ -5056,7 +5056,7 @@
                 </a:solidFill>
                 <a:latin typeface="Roboto Condensed"/>
               </a:rPr>
-              <a:t>MODO 2 · ROJO</a:t>
+              <a:t>MODO C · ROJO</a:t>
             </a:r>
           </a:p>
         </p:txBody>
@@ -5207,7 +5207,7 @@
                 </a:solidFill>
                 <a:latin typeface="Roboto Condensed"/>
               </a:rPr>
-              <a:t>MODO 3 · AMARILLO</a:t>
+              <a:t>MODO D · AMARILLO</a:t>
             </a:r>
           </a:p>
         </p:txBody>
@@ -5358,7 +5358,7 @@
                 </a:solidFill>
                 <a:latin typeface="Roboto Condensed"/>
               </a:rPr>
-              <a:t>MODO 4 · AZUL</a:t>
+              <a:t>MODO A · AZUL</a:t>
             </a:r>
           </a:p>
         </p:txBody>
@@ -5555,7 +5555,7 @@
                 </a:solidFill>
                 <a:latin typeface="Caveat Brush"/>
               </a:rPr>
-              <a:t>4</a:t>
+              <a:t>A</a:t>
             </a:r>
           </a:p>
         </p:txBody>
@@ -5706,7 +5706,7 @@
                 </a:solidFill>
                 <a:latin typeface="Caveat Brush"/>
               </a:rPr>
-              <a:t>2</a:t>
+              <a:t>C</a:t>
             </a:r>
           </a:p>
         </p:txBody>
@@ -5857,7 +5857,7 @@
                 </a:solidFill>
                 <a:latin typeface="Caveat Brush"/>
               </a:rPr>
-              <a:t>3</a:t>
+              <a:t>D</a:t>
             </a:r>
           </a:p>
         </p:txBody>
@@ -6008,7 +6008,7 @@
                 </a:solidFill>
                 <a:latin typeface="Caveat Brush"/>
               </a:rPr>
-              <a:t>1</a:t>
+              <a:t>B</a:t>
             </a:r>
           </a:p>
         </p:txBody>
@@ -6288,7 +6288,7 @@
                 </a:solidFill>
                 <a:latin typeface="Caveat Brush"/>
               </a:rPr>
-              <a:t>4</a:t>
+              <a:t>A</a:t>
             </a:r>
           </a:p>
         </p:txBody>
@@ -6358,7 +6358,7 @@
                 </a:solidFill>
                 <a:latin typeface="Inter"/>
               </a:rPr>
-              <a:t>análisis y estrategia, modo 4.</a:t>
+              <a:t>análisis y estrategia, modo A.</a:t>
             </a:r>
           </a:p>
         </p:txBody>
@@ -6439,7 +6439,7 @@
                 </a:solidFill>
                 <a:latin typeface="Caveat Brush"/>
               </a:rPr>
-              <a:t>2</a:t>
+              <a:t>C</a:t>
             </a:r>
           </a:p>
         </p:txBody>
@@ -6509,7 +6509,7 @@
                 </a:solidFill>
                 <a:latin typeface="Inter"/>
               </a:rPr>
-              <a:t>personas y vínculos, modo 2.</a:t>
+              <a:t>personas y vínculos, modo C.</a:t>
             </a:r>
           </a:p>
         </p:txBody>
@@ -6590,7 +6590,7 @@
                 </a:solidFill>
                 <a:latin typeface="Caveat Brush"/>
               </a:rPr>
-              <a:t>3</a:t>
+              <a:t>D</a:t>
             </a:r>
           </a:p>
         </p:txBody>
@@ -6660,7 +6660,7 @@
                 </a:solidFill>
                 <a:latin typeface="Inter"/>
               </a:rPr>
-              <a:t>visión e intuición, modo 3.</a:t>
+              <a:t>visión e intuición, modo D.</a:t>
             </a:r>
           </a:p>
         </p:txBody>
@@ -6949,7 +6949,7 @@
                 </a:solidFill>
                 <a:latin typeface="Inter"/>
               </a:rPr>
-              <a:t>1 · Verde</a:t>
+              <a:t>B · Verde</a:t>
             </a:r>
           </a:p>
         </p:txBody>
@@ -7240,7 +7240,7 @@
                 </a:solidFill>
                 <a:latin typeface="Inter"/>
               </a:rPr>
-              <a:t>2 · Rojo</a:t>
+              <a:t>C · Rojo</a:t>
             </a:r>
           </a:p>
         </p:txBody>
@@ -7671,7 +7671,7 @@
                 </a:solidFill>
                 <a:latin typeface="Inter"/>
               </a:rPr>
-              <a:t>3 · Amarillo</a:t>
+              <a:t>D · Amarillo</a:t>
             </a:r>
           </a:p>
         </p:txBody>
@@ -7892,7 +7892,7 @@
                 </a:solidFill>
                 <a:latin typeface="Inter"/>
               </a:rPr>
-              <a:t>4 · Azul</a:t>
+              <a:t>A · Azul</a:t>
             </a:r>
           </a:p>
         </p:txBody>
@@ -8474,7 +8474,7 @@
             </a:avLst>
           </a:prstGeom>
           <a:solidFill>
-            <a:srgbClr val="2F7A52"/>
+            <a:srgbClr val="2B5C9A"/>
           </a:solidFill>
           <a:ln>
             <a:noFill/>
@@ -8533,7 +8533,7 @@
                 </a:solidFill>
                 <a:latin typeface="Caveat Brush"/>
               </a:rPr>
-              <a:t>1</a:t>
+              <a:t>A</a:t>
             </a:r>
           </a:p>
         </p:txBody>
@@ -8568,7 +8568,7 @@
                 </a:solidFill>
                 <a:latin typeface="Inter"/>
               </a:rPr>
-              <a:t>Verde</a:t>
+              <a:t>Azul</a:t>
             </a:r>
           </a:p>
         </p:txBody>
@@ -8607,7 +8607,7 @@
                 </a:solidFill>
                 <a:latin typeface="Inter"/>
               </a:rPr>
-              <a:t>Ordenamos, planificamos y cumplimos.</a:t>
+              <a:t>Decidimos con datos y criterio técnico.</a:t>
             </a:r>
           </a:p>
         </p:txBody>
@@ -8646,7 +8646,7 @@
                 </a:solidFill>
                 <a:latin typeface="Inter"/>
               </a:rPr>
-              <a:t>La rigidez: “siempre se hizo así”.</a:t>
+              <a:t>Olvidar el efecto en las personas.</a:t>
             </a:r>
           </a:p>
         </p:txBody>
@@ -8714,7 +8714,7 @@
             </a:avLst>
           </a:prstGeom>
           <a:solidFill>
-            <a:srgbClr val="C0492F"/>
+            <a:srgbClr val="2F7A52"/>
           </a:solidFill>
           <a:ln>
             <a:noFill/>
@@ -8773,7 +8773,7 @@
                 </a:solidFill>
                 <a:latin typeface="Caveat Brush"/>
               </a:rPr>
-              <a:t>2</a:t>
+              <a:t>B</a:t>
             </a:r>
           </a:p>
         </p:txBody>
@@ -8808,7 +8808,7 @@
                 </a:solidFill>
                 <a:latin typeface="Inter"/>
               </a:rPr>
-              <a:t>Rojo</a:t>
+              <a:t>Verde</a:t>
             </a:r>
           </a:p>
         </p:txBody>
@@ -8847,7 +8847,7 @@
                 </a:solidFill>
                 <a:latin typeface="Inter"/>
               </a:rPr>
-              <a:t>Cuidamos a la gente y sostenemos el clima.</a:t>
+              <a:t>Ordenamos, planificamos y cumplimos.</a:t>
             </a:r>
           </a:p>
         </p:txBody>
@@ -8886,7 +8886,7 @@
                 </a:solidFill>
                 <a:latin typeface="Inter"/>
               </a:rPr>
-              <a:t>Esquivar la conversación difícil.</a:t>
+              <a:t>La rigidez: “siempre se hizo así”.</a:t>
             </a:r>
           </a:p>
         </p:txBody>
@@ -8954,7 +8954,7 @@
             </a:avLst>
           </a:prstGeom>
           <a:solidFill>
-            <a:srgbClr val="E2A62A"/>
+            <a:srgbClr val="C0492F"/>
           </a:solidFill>
           <a:ln>
             <a:noFill/>
@@ -9009,11 +9009,11 @@
             <a:r>
               <a:rPr sz="4000" b="0" i="0">
                 <a:solidFill>
-                  <a:srgbClr val="002060"/>
+                  <a:srgbClr val="FFFFFF"/>
                 </a:solidFill>
                 <a:latin typeface="Caveat Brush"/>
               </a:rPr>
-              <a:t>3</a:t>
+              <a:t>C</a:t>
             </a:r>
           </a:p>
         </p:txBody>
@@ -9044,11 +9044,11 @@
             <a:r>
               <a:rPr sz="1600" b="1" i="0">
                 <a:solidFill>
-                  <a:srgbClr val="002060"/>
+                  <a:srgbClr val="FFFFFF"/>
                 </a:solidFill>
                 <a:latin typeface="Inter"/>
               </a:rPr>
-              <a:t>Amarillo</a:t>
+              <a:t>Rojo</a:t>
             </a:r>
           </a:p>
         </p:txBody>
@@ -9087,7 +9087,7 @@
                 </a:solidFill>
                 <a:latin typeface="Inter"/>
               </a:rPr>
-              <a:t>Marcamos rumbo y animamos al cambio.</a:t>
+              <a:t>Cuidamos a la gente y sostenemos el clima.</a:t>
             </a:r>
           </a:p>
         </p:txBody>
@@ -9126,7 +9126,7 @@
                 </a:solidFill>
                 <a:latin typeface="Inter"/>
               </a:rPr>
-              <a:t>Dejar proyectos a medio sembrar.</a:t>
+              <a:t>Esquivar la conversación difícil.</a:t>
             </a:r>
           </a:p>
         </p:txBody>
@@ -9194,7 +9194,7 @@
             </a:avLst>
           </a:prstGeom>
           <a:solidFill>
-            <a:srgbClr val="2B5C9A"/>
+            <a:srgbClr val="E2A62A"/>
           </a:solidFill>
           <a:ln>
             <a:noFill/>
@@ -9249,11 +9249,11 @@
             <a:r>
               <a:rPr sz="4000" b="0" i="0">
                 <a:solidFill>
-                  <a:srgbClr val="FFFFFF"/>
+                  <a:srgbClr val="002060"/>
                 </a:solidFill>
                 <a:latin typeface="Caveat Brush"/>
               </a:rPr>
-              <a:t>4</a:t>
+              <a:t>D</a:t>
             </a:r>
           </a:p>
         </p:txBody>
@@ -9284,11 +9284,11 @@
             <a:r>
               <a:rPr sz="1600" b="1" i="0">
                 <a:solidFill>
-                  <a:srgbClr val="FFFFFF"/>
+                  <a:srgbClr val="002060"/>
                 </a:solidFill>
                 <a:latin typeface="Inter"/>
               </a:rPr>
-              <a:t>Azul</a:t>
+              <a:t>Amarillo</a:t>
             </a:r>
           </a:p>
         </p:txBody>
@@ -9327,7 +9327,7 @@
                 </a:solidFill>
                 <a:latin typeface="Inter"/>
               </a:rPr>
-              <a:t>Decidimos con datos y criterio técnico.</a:t>
+              <a:t>Marcamos rumbo y animamos al cambio.</a:t>
             </a:r>
           </a:p>
         </p:txBody>
@@ -9366,7 +9366,7 @@
                 </a:solidFill>
                 <a:latin typeface="Inter"/>
               </a:rPr>
-              <a:t>Olvidar el efecto en las personas.</a:t>
+              <a:t>Dejar proyectos a medio sembrar.</a:t>
             </a:r>
           </a:p>
         </p:txBody>
@@ -9576,7 +9576,7 @@
                 </a:solidFill>
                 <a:latin typeface="Caveat Brush"/>
               </a:rPr>
-              <a:t>1</a:t>
+              <a:t>B</a:t>
             </a:r>
           </a:p>
         </p:txBody>
@@ -9731,7 +9731,7 @@
                 </a:solidFill>
                 <a:latin typeface="Caveat Brush"/>
               </a:rPr>
-              <a:t>2</a:t>
+              <a:t>C</a:t>
             </a:r>
           </a:p>
         </p:txBody>
@@ -9886,7 +9886,7 @@
                 </a:solidFill>
                 <a:latin typeface="Caveat Brush"/>
               </a:rPr>
-              <a:t>3</a:t>
+              <a:t>D</a:t>
             </a:r>
           </a:p>
         </p:txBody>
@@ -10041,7 +10041,7 @@
                 </a:solidFill>
                 <a:latin typeface="Caveat Brush"/>
               </a:rPr>
-              <a:t>4</a:t>
+              <a:t>A</a:t>
             </a:r>
           </a:p>
         </p:txBody>
@@ -11079,7 +11079,7 @@
                 </a:solidFill>
                 <a:latin typeface="Caveat Brush"/>
               </a:rPr>
-              <a:t>1</a:t>
+              <a:t>B</a:t>
             </a:r>
           </a:p>
         </p:txBody>
@@ -11160,7 +11160,7 @@
                 </a:solidFill>
                 <a:latin typeface="Caveat Brush"/>
               </a:rPr>
-              <a:t>2</a:t>
+              <a:t>C</a:t>
             </a:r>
           </a:p>
         </p:txBody>
@@ -11241,7 +11241,7 @@
                 </a:solidFill>
                 <a:latin typeface="Caveat Brush"/>
               </a:rPr>
-              <a:t>3</a:t>
+              <a:t>D</a:t>
             </a:r>
           </a:p>
         </p:txBody>
@@ -11322,7 +11322,7 @@
                 </a:solidFill>
                 <a:latin typeface="Caveat Brush"/>
               </a:rPr>
-              <a:t>4</a:t>
+              <a:t>A</a:t>
             </a:r>
           </a:p>
         </p:txBody>

</xml_diff>